<commit_message>
Update remaining local document changes
</commit_message>
<xml_diff>
--- a/1. 일정/1. Weekly Plan/보고자료/프로젝트/2026/0409/0407/일일 보고_조현진_260407.pptx
+++ b/1. 일정/1. Weekly Plan/보고자료/프로젝트/2026/0409/0407/일일 보고_조현진_260407.pptx
@@ -287,7 +287,7 @@
               <a:pPr>
                 <a:defRPr/>
               </a:pPr>
-              <a:t>2026-04-07</a:t>
+              <a:t>2026-04-08</a:t>
             </a:fld>
             <a:endParaRPr lang="ko-KR" altLang="en-US"/>
           </a:p>
@@ -508,7 +508,7 @@
               <a:pPr>
                 <a:defRPr/>
               </a:pPr>
-              <a:t>2026-04-07</a:t>
+              <a:t>2026-04-08</a:t>
             </a:fld>
             <a:endParaRPr lang="ko-KR" altLang="en-US"/>
           </a:p>
@@ -3970,7 +3970,7 @@
         </p:nvGraphicFramePr>
         <p:xfrm>
           <a:off x="60663" y="620689"/>
-          <a:ext cx="9047224" cy="5770677"/>
+          <a:ext cx="9047224" cy="5757850"/>
         </p:xfrm>
         <a:graphic>
           <a:graphicData uri="http://schemas.openxmlformats.org/drawingml/2006/table">
@@ -5166,14 +5166,6 @@
                         </a:rPr>
                         <a:t>Y2V</a:t>
                       </a:r>
-                      <a:endParaRPr lang="en-US" altLang="ko-KR" sz="900" b="0" kern="1200" dirty="0" smtClean="0">
-                        <a:solidFill>
-                          <a:schemeClr val="tx1"/>
-                        </a:solidFill>
-                        <a:latin typeface="+mn-lt"/>
-                        <a:ea typeface="맑은 고딕"/>
-                        <a:cs typeface="+mn-cs"/>
-                      </a:endParaRPr>
                     </a:p>
                   </a:txBody>
                   <a:tcPr marL="86400" marR="86400" marT="43277" marB="43277" anchor="ctr" horzOverflow="overflow">
@@ -5795,19 +5787,7 @@
                           <a:ea typeface="+mn-ea"/>
                           <a:cs typeface="+mn-cs"/>
                         </a:rPr>
-                        <a:t>- </a:t>
-                      </a:r>
-                      <a:r>
-                        <a:rPr lang="en-US" altLang="ko-KR" sz="900" b="0" i="0" u="none" strike="noStrike" kern="1200" dirty="0" smtClean="0">
-                          <a:solidFill>
-                            <a:schemeClr val="tx1"/>
-                          </a:solidFill>
-                          <a:effectLst/>
-                          <a:latin typeface="+mn-lt"/>
-                          <a:ea typeface="+mn-ea"/>
-                          <a:cs typeface="+mn-cs"/>
-                        </a:rPr>
-                        <a:t>2026-04-07】</a:t>
+                        <a:t>- 2026-04-07】</a:t>
                       </a:r>
                     </a:p>
                     <a:p>
@@ -7359,7 +7339,7 @@
           <a:graphicData uri="http://schemas.openxmlformats.org/presentationml/2006/ole">
             <mc:AlternateContent xmlns:mc="http://schemas.openxmlformats.org/markup-compatibility/2006">
               <mc:Choice xmlns:v="urn:schemas-microsoft-com:vml" Requires="v">
-                <p:oleObj spid="_x0000_s1147" name="워크시트" showAsIcon="1" r:id="rId4" imgW="380880" imgH="771480" progId="Excel.Sheet.12">
+                <p:oleObj spid="_x0000_s1149" name="워크시트" showAsIcon="1" r:id="rId4" imgW="380880" imgH="771480" progId="Excel.Sheet.12">
                   <p:embed/>
                 </p:oleObj>
               </mc:Choice>
@@ -10735,7 +10715,7 @@
           <a:graphicData uri="http://schemas.openxmlformats.org/presentationml/2006/ole">
             <mc:AlternateContent xmlns:mc="http://schemas.openxmlformats.org/markup-compatibility/2006">
               <mc:Choice xmlns:v="urn:schemas-microsoft-com:vml" Requires="v">
-                <p:oleObj spid="_x0000_s1148" name="문서" showAsIcon="1" r:id="rId6" imgW="914400" imgH="771480" progId="Word.Document.12">
+                <p:oleObj spid="_x0000_s1150" name="문서" showAsIcon="1" r:id="rId6" imgW="914400" imgH="771480" progId="Word.Document.12">
                   <p:embed/>
                 </p:oleObj>
               </mc:Choice>
@@ -10784,7 +10764,7 @@
     <mc:Choice Requires="p14">
       <p:transition/>
     </mc:Choice>
-    <mc:Fallback xmlns:dsp="http://schemas.microsoft.com/office/drawing/2008/diagram" xmlns:dgm="http://schemas.openxmlformats.org/drawingml/2006/diagram" xmlns:c="http://schemas.openxmlformats.org/drawingml/2006/chart" xmlns="">
+    <mc:Fallback xmlns="" xmlns:c="http://schemas.openxmlformats.org/drawingml/2006/chart" xmlns:dgm="http://schemas.openxmlformats.org/drawingml/2006/diagram" xmlns:dsp="http://schemas.microsoft.com/office/drawing/2008/diagram">
       <p:transition/>
     </mc:Fallback>
   </mc:AlternateContent>
@@ -10817,7 +10797,7 @@
           <p:nvPr>
             <p:extLst>
               <p:ext uri="{D42A27DB-BD31-4B8C-83A1-F6EECF244321}">
-                <p14:modId xmlns:p14="http://schemas.microsoft.com/office/powerpoint/2010/main" val="826908833"/>
+                <p14:modId xmlns:p14="http://schemas.microsoft.com/office/powerpoint/2010/main" val="2850391626"/>
               </p:ext>
             </p:extLst>
           </p:nvPr>
@@ -12476,29 +12456,8 @@
                           <a:ea typeface="+mn-ea"/>
                           <a:cs typeface="+mn-cs"/>
                         </a:rPr>
-                        <a:t>- </a:t>
-                      </a:r>
-                      <a:r>
-                        <a:rPr lang="en-US" altLang="ko-KR" sz="900" b="0" i="0" u="none" strike="noStrike" kern="1200" dirty="0" smtClean="0">
-                          <a:solidFill>
-                            <a:schemeClr val="tx1"/>
-                          </a:solidFill>
-                          <a:effectLst/>
-                          <a:latin typeface="+mn-lt"/>
-                          <a:ea typeface="+mn-ea"/>
-                          <a:cs typeface="+mn-cs"/>
-                        </a:rPr>
-                        <a:t>2026-04-06】</a:t>
-                      </a:r>
-                      <a:endParaRPr lang="en-US" altLang="ko-KR" sz="900" b="0" i="0" u="none" strike="noStrike" kern="1200" dirty="0" smtClean="0">
-                        <a:solidFill>
-                          <a:schemeClr val="tx1"/>
-                        </a:solidFill>
-                        <a:effectLst/>
-                        <a:latin typeface="+mn-lt"/>
-                        <a:ea typeface="+mn-ea"/>
-                        <a:cs typeface="+mn-cs"/>
-                      </a:endParaRPr>
+                        <a:t>- 2026-04-06】</a:t>
+                      </a:r>
                     </a:p>
                     <a:p>
                       <a:pPr marL="171450" marR="0" indent="-171450" algn="l" defTabSz="914400" rtl="0" eaLnBrk="1" fontAlgn="base" latinLnBrk="1" hangingPunct="1">
@@ -12698,29 +12657,8 @@
                           <a:ea typeface="+mn-ea"/>
                           <a:cs typeface="+mn-cs"/>
                         </a:rPr>
-                        <a:t>- </a:t>
-                      </a:r>
-                      <a:r>
-                        <a:rPr lang="en-US" altLang="ko-KR" sz="900" b="0" i="0" u="none" strike="noStrike" kern="1200" dirty="0" smtClean="0">
-                          <a:solidFill>
-                            <a:schemeClr val="tx1"/>
-                          </a:solidFill>
-                          <a:effectLst/>
-                          <a:latin typeface="+mn-lt"/>
-                          <a:ea typeface="+mn-ea"/>
-                          <a:cs typeface="+mn-cs"/>
-                        </a:rPr>
-                        <a:t>2026-04-07】</a:t>
-                      </a:r>
-                      <a:endParaRPr lang="en-US" altLang="ko-KR" sz="900" b="0" i="0" u="none" strike="noStrike" kern="1200" dirty="0" smtClean="0">
-                        <a:solidFill>
-                          <a:schemeClr val="tx1"/>
-                        </a:solidFill>
-                        <a:effectLst/>
-                        <a:latin typeface="+mn-lt"/>
-                        <a:ea typeface="+mn-ea"/>
-                        <a:cs typeface="+mn-cs"/>
-                      </a:endParaRPr>
+                        <a:t>- 2026-04-07】</a:t>
+                      </a:r>
                     </a:p>
                   </a:txBody>
                   <a:tcPr marL="86360" marR="86360" marT="43307" marB="43307">
@@ -13107,7 +13045,7 @@
                         <a:t> Rear ES90700-00 </a:t>
                       </a:r>
                       <a:r>
-                        <a:rPr lang="ko-KR" altLang="en-US" sz="900" b="0" i="0" u="none" strike="noStrike" kern="1200" baseline="0" dirty="0" err="1" smtClean="0">
+                        <a:rPr lang="ko-KR" altLang="en-US" sz="900" b="0" i="0" u="none" strike="noStrike" kern="1200" baseline="0" err="1" smtClean="0">
                           <a:solidFill>
                             <a:schemeClr val="tx1"/>
                           </a:solidFill>
@@ -13119,7 +13057,7 @@
                         <a:t>재송부</a:t>
                       </a:r>
                       <a:r>
-                        <a:rPr lang="en-US" altLang="ko-KR" sz="900" b="0" i="0" u="none" strike="noStrike" kern="1200" baseline="0" dirty="0" smtClean="0">
+                        <a:rPr lang="en-US" altLang="ko-KR" sz="900" b="0" i="0" u="none" strike="noStrike" kern="1200" baseline="0" smtClean="0">
                           <a:solidFill>
                             <a:schemeClr val="tx1"/>
                           </a:solidFill>
@@ -13131,6 +13069,18 @@
                         <a:t>(</a:t>
                       </a:r>
                       <a:r>
+                        <a:rPr lang="ko-KR" altLang="en-US" sz="900" b="0" i="0" u="none" strike="noStrike" kern="1200" baseline="0" smtClean="0">
+                          <a:solidFill>
+                            <a:schemeClr val="tx1"/>
+                          </a:solidFill>
+                          <a:effectLst/>
+                          <a:latin typeface="+mn-lt"/>
+                          <a:ea typeface="+mn-ea"/>
+                          <a:cs typeface="+mn-cs"/>
+                        </a:rPr>
+                        <a:t>회신 </a:t>
+                      </a:r>
+                      <a:r>
                         <a:rPr lang="ko-KR" altLang="en-US" sz="900" b="0" i="0" u="none" strike="noStrike" kern="1200" baseline="0" dirty="0" smtClean="0">
                           <a:solidFill>
                             <a:schemeClr val="tx1"/>
@@ -13140,7 +13090,7 @@
                           <a:ea typeface="+mn-ea"/>
                           <a:cs typeface="+mn-cs"/>
                         </a:rPr>
-                        <a:t>화신 완</a:t>
+                        <a:t>완</a:t>
                       </a:r>
                       <a:r>
                         <a:rPr lang="en-US" altLang="ko-KR" sz="900" b="0" i="0" u="none" strike="noStrike" kern="1200" baseline="0" dirty="0" smtClean="0">
@@ -14047,19 +13997,7 @@
                           <a:ea typeface="+mn-ea"/>
                           <a:cs typeface="+mn-cs"/>
                         </a:rPr>
-                        <a:t> </a:t>
-                      </a:r>
-                      <a:r>
-                        <a:rPr lang="en-US" altLang="ko-KR" sz="900" b="0" i="0" u="none" strike="noStrike" kern="1200" baseline="0" dirty="0" smtClean="0">
-                          <a:solidFill>
-                            <a:schemeClr val="tx1"/>
-                          </a:solidFill>
-                          <a:effectLst/>
-                          <a:latin typeface="+mn-lt"/>
-                          <a:ea typeface="+mn-ea"/>
-                          <a:cs typeface="+mn-cs"/>
-                        </a:rPr>
-                        <a:t>Chain </a:t>
+                        <a:t> Chain </a:t>
                       </a:r>
                       <a:r>
                         <a:rPr lang="ko-KR" altLang="en-US" sz="900" b="0" i="0" u="none" strike="noStrike" kern="1200" baseline="0" dirty="0" smtClean="0">
@@ -16209,7 +16147,7 @@
           <a:graphicData uri="http://schemas.openxmlformats.org/presentationml/2006/ole">
             <mc:AlternateContent xmlns:mc="http://schemas.openxmlformats.org/markup-compatibility/2006">
               <mc:Choice xmlns:v="urn:schemas-microsoft-com:vml" Requires="v">
-                <p:oleObj spid="_x0000_s2055" name="워크시트" showAsIcon="1" r:id="rId4" imgW="380880" imgH="771480" progId="Excel.Sheet.12">
+                <p:oleObj spid="_x0000_s2056" name="워크시트" showAsIcon="1" r:id="rId4" imgW="380880" imgH="771480" progId="Excel.Sheet.12">
                   <p:embed/>
                 </p:oleObj>
               </mc:Choice>
@@ -19577,7 +19515,7 @@
     <mc:Choice Requires="p14">
       <p:transition/>
     </mc:Choice>
-    <mc:Fallback xmlns:dsp="http://schemas.microsoft.com/office/drawing/2008/diagram" xmlns:dgm="http://schemas.openxmlformats.org/drawingml/2006/diagram" xmlns:c="http://schemas.openxmlformats.org/drawingml/2006/chart" xmlns="">
+    <mc:Fallback xmlns="" xmlns:c="http://schemas.openxmlformats.org/drawingml/2006/chart" xmlns:dgm="http://schemas.openxmlformats.org/drawingml/2006/diagram" xmlns:dsp="http://schemas.microsoft.com/office/drawing/2008/diagram">
       <p:transition/>
     </mc:Fallback>
   </mc:AlternateContent>

</xml_diff>